<commit_message>
Scenario 2 deck: describe snowball coupon as simple accrual, not compounding
The coupon accrues 2.25% per quarter (simple interest); 145% at Y5 is about
7.7% p.a. compounded. Fix the title, executive summary, client and term-sheet
wording, and state the compounded equivalent on the payoff slide.

Co-Authored-By: Claude Opus 5.5 <noreply@anthropic.com>
Claude-Session: https://claude.ai/code/session_01Rwoh8cFDQqLD8JWT3mee6y
</commit_message>
<xml_diff>
--- a/deck/Asian-Digital-Snowball-Note.pptx
+++ b/deck/Asian-Digital-Snowball-Note.pptx
@@ -14804,7 +14804,7 @@
                 <a:ea typeface="Calibri" pitchFamily="34" charset="-122"/>
                 <a:cs typeface="Calibri" pitchFamily="34" charset="-120"/>
               </a:rPr>
-              <a:t>Growth that compounds while Asia digitalises, with capital protected unless the basket is down more than 35% at maturity</a:t>
+              <a:t>Growth that accrues while Asia digitalises, with capital protected unless the basket is down more than 35% at maturity</a:t>
             </a:r>
             <a:endParaRPr lang="en-US" sz="1500" dirty="0"/>
           </a:p>
@@ -29602,7 +29602,7 @@
                 <a:ea typeface="Calibri" pitchFamily="34" charset="-122"/>
                 <a:cs typeface="Calibri" pitchFamily="34" charset="-120"/>
               </a:rPr>
-              <a:t>One note that turns the family's operating expertise into compounding, protected growth</a:t>
+              <a:t>One note that turns the family's operating expertise into accruing, protected growth</a:t>
             </a:r>
             <a:endParaRPr lang="en-US" sz="1250" dirty="0"/>
           </a:p>
@@ -30115,7 +30115,7 @@
                 <a:ea typeface="Calibri" pitchFamily="34" charset="-122"/>
                 <a:cs typeface="Calibri" pitchFamily="34" charset="-120"/>
               </a:rPr>
-              <a:t>The coupon compounds into capital rather than paying income, which matches a growth mandate. A diversified basket (not worst-of) and a maturity-only barrier make it suitable for generational wealth. Fair value is 97.3%, so issuing at par leaves Natixis 2.7% to cover hedging and margin.</a:t>
+              <a:t>The coupon accrues and is paid with capital at call rather than as income, which matches a growth mandate. A diversified basket (not worst-of) and a maturity-only barrier make it suitable for generational wealth. Fair value is 97.3%, so issuing at par leaves Natixis 2.7% to cover hedging and margin.</a:t>
             </a:r>
             <a:endParaRPr lang="en-US" sz="1150" dirty="0"/>
           </a:p>
@@ -30955,7 +30955,7 @@
                           <a:ea typeface="Calibri" pitchFamily="34" charset="-122"/>
                           <a:cs typeface="Calibri" pitchFamily="34" charset="-120"/>
                         </a:rPr>
-                        <a:t>Snowball coupon: 9% p.a. accrues and is paid with principal, so value compounds instead of leaking out as income</a:t>
+                        <a:t>Snowball coupon: 9% p.a. accrues and is paid with principal, so value builds up instead of leaking out as income</a:t>
                       </a:r>
                       <a:endParaRPr lang="en-US" sz="950" dirty="0">
                         <a:latin typeface="Calibri" charset="0"/>
@@ -34549,7 +34549,7 @@
                 <a:ea typeface="Calibri" pitchFamily="34" charset="-122"/>
                 <a:cs typeface="Calibri" pitchFamily="34" charset="-120"/>
               </a:rPr>
-              <a:t>Why snowball: same risk as an income autocall, but a much higher coupon and true compounding</a:t>
+              <a:t>Why snowball: same risk as an income autocall, but a much higher coupon that accrues until paid</a:t>
             </a:r>
             <a:endParaRPr lang="en-US" sz="1250" dirty="0"/>
           </a:p>
@@ -38208,7 +38208,7 @@
                 <a:ea typeface="Calibri" pitchFamily="34" charset="-122"/>
                 <a:cs typeface="Calibri" pitchFamily="34" charset="-120"/>
               </a:rPr>
-              <a:t>Coupon grows linearly; there is no compounding cap until maturity. The longer the wait, the bigger the payout.</a:t>
+              <a:t>Coupon accrues as simple interest: 2.25% per quarter. The longer the wait, the bigger the payout (145% at Y5 ≈ 7.7% p.a. compounded).</a:t>
             </a:r>
             <a:endParaRPr lang="en-US" sz="900" dirty="0"/>
           </a:p>

</xml_diff>